<commit_message>
Count the learned-scorer tests and note the transfer result
Stacked on the learned-scorer PR now, so test_memgate.py has 78 tests and
memgate/ is ~8,200 lines. The remaining-work table records the pooled
scorer's held-out result. Deck and data.js rebuilt.

Co-Authored-By: Claude Opus 5.5 (1M context) <noreply@anthropic.com>
Claude-Session: https://claude.ai/code/session_01L4F5xzGCEyXAzeewiM3hbL
</commit_message>
<xml_diff>
--- a/MemGate_Capstone_Review2_NMIMS.pptx
+++ b/MemGate_Capstone_Review2_NMIMS.pptx
@@ -627,13 +627,13 @@
           <a:p/>
           <a:p>
             <a:r>
-              <a:t>P1-S, scored selection that drops whole turns, beats RAG store-all at every budget, by 3.9 to 8.7 points. At S = 4096 it is 36.8 against 28.1. Compression, P1-A, sits in between.</a:t>
+              <a:t>P1-S, scored selection that drops whole turns, beats RAG store-all at every budget, by 2.8 to 13.5 points. At S = 4096 it is 37.5 against 28.1. Compression, P1-A, sits in between.</a:t>
             </a:r>
           </a:p>
           <a:p/>
           <a:p>
             <a:r>
-              <a:t>Notice that the metrics disagree again. P1-A wins evidence recall by 12.9 points at 8192 while losing answer recall by 6.9, because its summaries keep the IDs but not the content.</a:t>
+              <a:t>Notice that the metrics disagree again. P1-A wins evidence recall by 15.0 points at 8192 while losing answer recall by 3.4, because its summaries keep the IDs but not the content.</a:t>
             </a:r>
           </a:p>
           <a:p/>
@@ -715,13 +715,13 @@
           <a:p/>
           <a:p>
             <a:r>
-              <a:t>Selection over RAG on answer recall: +8.67 points, interval 4.8 to 14.3, p around 10 to the minus 4. That is significant.</a:t>
+              <a:t>Selection over RAG on answer recall: +9.37 points, interval 5.5 to 14.9, p around 3 in 100,000. That is significant.</a:t>
             </a:r>
           </a:p>
           <a:p/>
           <a:p>
             <a:r>
-              <a:t>On evidence recall, though, the gain over RAG is only 1.96 points, the interval crosses zero, and p is 0.16. So we do not claim an evidence-recall improvement over RAG. The comparisons against compression and against recency are all significant.</a:t>
+              <a:t>On evidence recall, though, the gain over RAG is only 2.42 points, the interval crosses zero, and p is 0.16. So we do not claim an evidence-recall improvement over RAG. The comparisons against compression and against recency are all significant.</a:t>
             </a:r>
           </a:p>
           <a:p/>
@@ -809,7 +809,7 @@
           <a:p/>
           <a:p>
             <a:r>
-              <a:t>There is no crossover anywhere, and selection's margin over RAG actually widens as the pressure rises. One caveat: concatenated streams are synthetic. This is a stress test, not a natural long conversation.</a:t>
+              <a:t>There is no crossover anywhere: selection stays ahead of both RAG and compression at every ratio. One caveat: concatenated streams are synthetic. This is a stress test, not a natural long conversation.</a:t>
             </a:r>
           </a:p>
         </p:txBody>
@@ -961,7 +961,7 @@
           <a:p/>
           <a:p>
             <a:r>
-              <a:t>So is the scorer the limit? We trained a learned scorer, evaluated leave-one-conversation-out, so it never sees the conversation it is scoring. With hand-built features it reaches an AUC of 0.746. Adding MiniLM embeddings takes it to 0.793 and lifts answer recall from 26.3 to 31.5 percent.</a:t>
+              <a:t>So is the scorer the limit? We trained a learned scorer, evaluated leave-one-conversation-out, so it never sees the conversation it is scoring. With hand-built features it reaches an AUC of 0.747, and only ties the hand-written rules. Adding MiniLM embeddings takes it to 0.793 and lifts answer recall from 27.8 to 30.5 percent, a modest gain.</a:t>
             </a:r>
           </a:p>
           <a:p/>
@@ -1137,7 +1137,7 @@
           <a:p/>
           <a:p>
             <a:r>
-              <a:t>P1-S reaches 18.5% accuracy against 12.4% for RAG. That means 6 points of the 8.7-point recall gap turn into correct answers, with a clustered interval of 3.3 to 9.1, so about 69% of the gap converts. Because closed-book is so low, nearly all of that margin comes from the memory system.</a:t>
+              <a:t>P1-S reaches 18.5% accuracy against 12.4% for RAG. That means 6 points of the 8.7-point recall gap of that run, which predates the scorer fix, turn into correct answers, with a clustered interval of 3.3 to 9.1, so about 69% of the gap converts. Because closed-book is so low, nearly all of that margin comes from the memory system.</a:t>
             </a:r>
           </a:p>
         </p:txBody>
@@ -1213,7 +1213,7 @@
           <a:p/>
           <a:p>
             <a:r>
-              <a:t>LoCoMo is only ten conversations. LongMemEval has 94 independent haystacks of 38 to 62 sessions each. At storage matched to LoCoMo's retention, about 22%, selection loses to FIFO by 21 answer points, where LoCoMo gave plus 8.7.</a:t>
+              <a:t>LoCoMo is only ten conversations. LongMemEval has 94 independent haystacks of 38 to 62 sessions each. At storage matched to LoCoMo's retention, about 22%, selection loses to FIFO by 21 answer points, where LoCoMo gave plus 9.4.</a:t>
             </a:r>
           </a:p>
           <a:p/>
@@ -1389,7 +1389,7 @@
           <a:p/>
           <a:p>
             <a:r>
-              <a:t>The headline: choosing which turns to forget, instead of forgetting the oldest first, is worth 8.7 answer-recall points. Storage, fidelity and retrieval are held identical. We'll also be upfront that on the second benchmark this result does not hold. Slides 18 and 19 show why.</a:t>
+              <a:t>The headline: choosing which turns to forget, instead of forgetting the oldest first, is worth 9.4 answer-recall points. Storage, fidelity and retrieval are held identical. We'll also be upfront that on the second benchmark this result does not hold. Slides 18 and 19 show why.</a:t>
             </a:r>
           </a:p>
           <a:p/>
@@ -1647,7 +1647,7 @@
           <a:p/>
           <a:p>
             <a:r>
-              <a:t>There are 68 regression tests, plus three label-blindness checks that re-run the leak test whenever we add a decision point. Offline pinning stops a half-downloaded model from silently relabelling a results table; that happened once with MiniLM. Then there is provenance logging, the NaN guard, caches keyed by model and prompt so long runs are reproducible and resumable, and results committed alongside the code.</a:t>
+              <a:t>There are 78 regression tests, plus three label-blindness checks that re-run the leak test whenever we add a decision point. Offline pinning stops a half-downloaded model from silently relabelling a results table; that happened once with MiniLM. Then there is provenance logging, the NaN guard, caches keyed by model and prompt so long runs are reproducible and resumable, and results committed alongside the code.</a:t>
             </a:r>
           </a:p>
           <a:p/>
@@ -1881,7 +1881,7 @@
           <a:p/>
           <a:p>
             <a:r>
-              <a:t>Ten conversations means wide intervals. Context recall is a ceiling on accuracy, not accuracy itself. Compression is now tested in both forms: rewriting beats word-selection by 4.1 points but still loses to dropping, at 1,850 times the cost. Concatenated streams are synthetic. We used one embedder and one judge model. P3 is an upper bound, not something an agent could run live. And the scorer is tuned to LoCoMo, so plus 8.7 is what selection recovers given a scorer that suits the corpus.</a:t>
+              <a:t>Ten conversations means wide intervals. Context recall is a ceiling on accuracy, not accuracy itself. Compression is now tested in both forms: rewriting beats word-selection by 4.1 points but still loses to dropping, at 1,850 times the cost. Concatenated streams are synthetic. We used one embedder and one judge model. P3 is an upper bound, not something an agent could run live. And the scorer is tuned to LoCoMo, so plus 9.4 is what selection recovers given a scorer that suits the corpus.</a:t>
             </a:r>
           </a:p>
           <a:p/>
@@ -1963,7 +1963,7 @@
           <a:p/>
           <a:p>
             <a:r>
-              <a:t>With storage unlimited, tiered compression is a net loss. With storage bounded, the decision policy is worth 8.7 answer-recall points, and compression still loses. The rate–distortion crossover is not reachable even at 182 times compression. Charging for the index flips the ranking below about 40 KiB. An LLM judge loses to a regex, for a reason we can diagnose. And on a second benchmark our headline does not replicate, because of the scorer, not the mechanism.</a:t>
+              <a:t>With storage unlimited, tiered compression is a net loss. With storage bounded, the decision policy is worth 9.4 answer-recall points, and compression still loses. The rate–distortion crossover is not reachable even at 182 times compression. Charging for the index flips the ranking below about 40 KiB. An LLM judge loses to a regex, for a reason we can diagnose. And on a second benchmark our headline does not replicate, because of the scorer, not the mechanism.</a:t>
             </a:r>
           </a:p>
           <a:p/>
@@ -14628,7 +14628,7 @@
                           </a:solidFill>
                           <a:latin typeface="Times New Roman"/>
                         </a:rPr>
-                        <a:t>71 tests (test_memgate.py)</a:t>
+                        <a:t>78 tests (test_memgate.py)</a:t>
                       </a:r>
                     </a:p>
                   </a:txBody>
@@ -15312,7 +15312,7 @@
                 </a:solidFill>
                 <a:latin typeface="Times New Roman"/>
               </a:rPr>
-              <a:t>— ~6,500 lines of Python: the library, 17 runnable experiments, 71 tests.</a:t>
+              <a:t>— ~8,200 lines of Python: the library, 17 runnable experiments, 78 tests.</a:t>
             </a:r>
           </a:p>
           <a:p>
@@ -23287,7 +23287,7 @@
                 </a:solidFill>
                 <a:latin typeface="Consolas"/>
               </a:rPr>
-              <a:t>    test_memgate.py               71 tests</a:t>
+              <a:t>    test_memgate.py               78 tests</a:t>
             </a:r>
           </a:p>
           <a:p>

</xml_diff>